<commit_message>
typos in week 5's slide
</commit_message>
<xml_diff>
--- a/Live-lecture-slides/CITS5503IAM_week5.pptx
+++ b/Live-lecture-slides/CITS5503IAM_week5.pptx
@@ -8024,7 +8024,7 @@
             <a:fld id="{B61BEF0D-F0BB-DE4B-95CE-6DB70DBA9567}" type="datetimeFigureOut">
               <a:rPr lang="en-US" smtClean="0"/>
               <a:pPr/>
-              <a:t>8/17/2026</a:t>
+              <a:t>8/23/2026</a:t>
             </a:fld>
             <a:endParaRPr lang="en-US" dirty="0"/>
           </a:p>
@@ -8224,7 +8224,7 @@
             <a:fld id="{B61BEF0D-F0BB-DE4B-95CE-6DB70DBA9567}" type="datetimeFigureOut">
               <a:rPr lang="en-US" smtClean="0"/>
               <a:pPr/>
-              <a:t>8/17/2026</a:t>
+              <a:t>8/23/2026</a:t>
             </a:fld>
             <a:endParaRPr lang="en-US" dirty="0"/>
           </a:p>
@@ -8439,7 +8439,7 @@
             <a:fld id="{B61BEF0D-F0BB-DE4B-95CE-6DB70DBA9567}" type="datetimeFigureOut">
               <a:rPr lang="en-US" smtClean="0"/>
               <a:pPr/>
-              <a:t>8/17/2026</a:t>
+              <a:t>8/23/2026</a:t>
             </a:fld>
             <a:endParaRPr lang="en-US" dirty="0"/>
           </a:p>
@@ -8979,7 +8979,7 @@
             <a:fld id="{B61BEF0D-F0BB-DE4B-95CE-6DB70DBA9567}" type="datetimeFigureOut">
               <a:rPr lang="en-US" smtClean="0"/>
               <a:pPr/>
-              <a:t>8/17/2026</a:t>
+              <a:t>8/23/2026</a:t>
             </a:fld>
             <a:endParaRPr lang="en-US" dirty="0"/>
           </a:p>
@@ -9257,7 +9257,7 @@
             <a:fld id="{B61BEF0D-F0BB-DE4B-95CE-6DB70DBA9567}" type="datetimeFigureOut">
               <a:rPr lang="en-US" smtClean="0"/>
               <a:pPr/>
-              <a:t>8/17/2026</a:t>
+              <a:t>8/23/2026</a:t>
             </a:fld>
             <a:endParaRPr lang="en-US" dirty="0"/>
           </a:p>
@@ -9529,7 +9529,7 @@
             <a:fld id="{B61BEF0D-F0BB-DE4B-95CE-6DB70DBA9567}" type="datetimeFigureOut">
               <a:rPr lang="en-US" smtClean="0"/>
               <a:pPr/>
-              <a:t>8/17/2026</a:t>
+              <a:t>8/23/2026</a:t>
             </a:fld>
             <a:endParaRPr lang="en-US" dirty="0"/>
           </a:p>
@@ -9948,7 +9948,7 @@
             <a:fld id="{B61BEF0D-F0BB-DE4B-95CE-6DB70DBA9567}" type="datetimeFigureOut">
               <a:rPr lang="en-US" smtClean="0"/>
               <a:pPr/>
-              <a:t>8/17/2026</a:t>
+              <a:t>8/23/2026</a:t>
             </a:fld>
             <a:endParaRPr lang="en-US" dirty="0"/>
           </a:p>
@@ -10096,7 +10096,7 @@
             <a:fld id="{B61BEF0D-F0BB-DE4B-95CE-6DB70DBA9567}" type="datetimeFigureOut">
               <a:rPr lang="en-US" smtClean="0"/>
               <a:pPr/>
-              <a:t>8/17/2026</a:t>
+              <a:t>8/23/2026</a:t>
             </a:fld>
             <a:endParaRPr lang="en-US" dirty="0"/>
           </a:p>
@@ -10216,7 +10216,7 @@
             <a:fld id="{B61BEF0D-F0BB-DE4B-95CE-6DB70DBA9567}" type="datetimeFigureOut">
               <a:rPr lang="en-US" smtClean="0"/>
               <a:pPr/>
-              <a:t>8/17/2026</a:t>
+              <a:t>8/23/2026</a:t>
             </a:fld>
             <a:endParaRPr lang="en-US" dirty="0"/>
           </a:p>
@@ -10534,7 +10534,7 @@
             <a:fld id="{B61BEF0D-F0BB-DE4B-95CE-6DB70DBA9567}" type="datetimeFigureOut">
               <a:rPr lang="en-US" smtClean="0"/>
               <a:pPr/>
-              <a:t>8/17/2026</a:t>
+              <a:t>8/23/2026</a:t>
             </a:fld>
             <a:endParaRPr lang="en-US" dirty="0"/>
           </a:p>
@@ -10829,7 +10829,7 @@
             <a:fld id="{B61BEF0D-F0BB-DE4B-95CE-6DB70DBA9567}" type="datetimeFigureOut">
               <a:rPr lang="en-US" smtClean="0"/>
               <a:pPr/>
-              <a:t>8/17/2026</a:t>
+              <a:t>8/23/2026</a:t>
             </a:fld>
             <a:endParaRPr lang="en-US" dirty="0"/>
           </a:p>
@@ -11077,7 +11077,7 @@
             <a:fld id="{B61BEF0D-F0BB-DE4B-95CE-6DB70DBA9567}" type="datetimeFigureOut">
               <a:rPr lang="en-US" smtClean="0"/>
               <a:pPr/>
-              <a:t>8/17/2026</a:t>
+              <a:t>8/23/2026</a:t>
             </a:fld>
             <a:endParaRPr lang="en-US" dirty="0"/>
           </a:p>
@@ -28173,7 +28173,7 @@
           <a:p>
             <a:pPr marL="49213" lvl="2" algn="l"/>
             <a:r>
-              <a:rPr lang="en-AU" sz="1800" i="1" dirty="0">
+              <a:rPr lang="en-AU" sz="1800" dirty="0">
                 <a:latin typeface="+mn-lt"/>
               </a:rPr>
               <a:t>  --table-name </a:t>
@@ -28185,43 +28185,37 @@
               <a:t>MusicAlbum</a:t>
             </a:r>
             <a:r>
-              <a:rPr lang="en-AU" sz="1800" i="1" dirty="0">
-                <a:latin typeface="+mn-lt"/>
-              </a:rPr>
-              <a:t> \</a:t>
-            </a:r>
-            <a:r>
               <a:rPr lang="en-AU" sz="1800" dirty="0">
                 <a:latin typeface="+mn-lt"/>
               </a:rPr>
-              <a:t> </a:t>
+              <a:t> \ </a:t>
             </a:r>
           </a:p>
           <a:p>
             <a:pPr marL="49213" lvl="2" algn="l"/>
             <a:r>
-              <a:rPr lang="en-AU" sz="1800" i="1" dirty="0">
-                <a:latin typeface="+mn-lt"/>
-              </a:rPr>
-              <a:t>  --item '{"Artist": {"S": “Tom"}, "Song": {"S": "Call Me Today"},  \</a:t>
+              <a:rPr lang="en-AU" sz="1800" dirty="0">
+                <a:latin typeface="+mn-lt"/>
+              </a:rPr>
+              <a:t>  --item '{"Artist": {"S": “Tom"}, "Song": {"S": "Call me today"},  \</a:t>
             </a:r>
           </a:p>
           <a:p>
             <a:pPr marL="49213" lvl="2" algn="l"/>
             <a:r>
-              <a:rPr lang="en-AU" sz="1800" i="1" dirty="0">
+              <a:rPr lang="en-AU" sz="1800" dirty="0">
                 <a:latin typeface="+mn-lt"/>
               </a:rPr>
               <a:t>              "</a:t>
             </a:r>
             <a:r>
-              <a:rPr lang="en-AU" sz="1800" i="1" dirty="0" err="1">
+              <a:rPr lang="en-AU" sz="1800" dirty="0" err="1">
                 <a:latin typeface="+mn-lt"/>
               </a:rPr>
               <a:t>AlbumTitle</a:t>
             </a:r>
             <a:r>
-              <a:rPr lang="en-AU" sz="1800" i="1" dirty="0">
+              <a:rPr lang="en-AU" sz="1800" dirty="0">
                 <a:latin typeface="+mn-lt"/>
               </a:rPr>
               <a:t>": {"S": "Somewhat Famous"}}’ \ </a:t>
@@ -28230,16 +28224,10 @@
           <a:p>
             <a:pPr marL="49213" lvl="2" algn="l"/>
             <a:r>
-              <a:rPr lang="en-AU" sz="1800" i="1" dirty="0">
-                <a:latin typeface="+mn-lt"/>
-              </a:rPr>
-              <a:t>  --return-consumed-capacity TOTAL </a:t>
-            </a:r>
-            <a:r>
               <a:rPr lang="en-AU" sz="1800" dirty="0">
                 <a:latin typeface="+mn-lt"/>
               </a:rPr>
-              <a:t>--endpoint-</a:t>
+              <a:t>  --return-consumed-capacity TOTAL --endpoint-</a:t>
             </a:r>
             <a:r>
               <a:rPr lang="en-AU" sz="1800" dirty="0" err="1">
@@ -28253,9 +28241,6 @@
               </a:rPr>
               <a:t>=http://localhost:8000</a:t>
             </a:r>
-            <a:endParaRPr lang="en-AU" sz="1800" i="1" dirty="0">
-              <a:latin typeface="+mn-lt"/>
-            </a:endParaRPr>
           </a:p>
         </p:txBody>
       </p:sp>

</xml_diff>